<commit_message>
fine tune speed modification
</commit_message>
<xml_diff>
--- a/9_FlySimulation/images/manual.pptx
+++ b/9_FlySimulation/images/manual.pptx
@@ -5,10 +5,11 @@
     <p:sldMasterId id="2147483648" r:id="rId1"/>
   </p:sldMasterIdLst>
   <p:notesMasterIdLst>
-    <p:notesMasterId r:id="rId5"/>
+    <p:notesMasterId r:id="rId6"/>
   </p:notesMasterIdLst>
   <p:sldIdLst>
     <p:sldId id="256" r:id="rId4"/>
+    <p:sldId id="257" r:id="rId5"/>
   </p:sldIdLst>
   <p:sldSz cx="12192000" cy="6858000"/>
   <p:notesSz cx="6858000" cy="9144000"/>
@@ -134,7 +135,7 @@
       </p:grpSpPr>
       <p:sp>
         <p:nvSpPr>
-          <p:cNvPr id="1073958467" name="標題佔位符 1"/>
+          <p:cNvPr id="1510672474" name="標題佔位符 1"/>
           <p:cNvSpPr>
             <a:spLocks noGrp="1"/>
           </p:cNvSpPr>
@@ -168,7 +169,7 @@
       </p:sp>
       <p:sp>
         <p:nvSpPr>
-          <p:cNvPr id="1906844019" name="日期佔位符 2"/>
+          <p:cNvPr id="1295217460" name="日期佔位符 2"/>
           <p:cNvSpPr>
             <a:spLocks noGrp="1"/>
           </p:cNvSpPr>
@@ -206,7 +207,7 @@
       </p:sp>
       <p:sp>
         <p:nvSpPr>
-          <p:cNvPr id="872312973" name="幻燈片圖像佔位符 3"/>
+          <p:cNvPr id="1906794991" name="幻燈片圖像佔位符 3"/>
           <p:cNvSpPr>
             <a:spLocks noChangeAspect="1" noGrp="1" noRot="1"/>
           </p:cNvSpPr>
@@ -242,7 +243,7 @@
       </p:sp>
       <p:sp>
         <p:nvSpPr>
-          <p:cNvPr id="1768480475" name="備註 佔位符 4"/>
+          <p:cNvPr id="1011862483" name="備註 佔位符 4"/>
           <p:cNvSpPr>
             <a:spLocks noGrp="1"/>
           </p:cNvSpPr>
@@ -316,7 +317,7 @@
       </p:sp>
       <p:sp>
         <p:nvSpPr>
-          <p:cNvPr id="1276077151" name="頁腳佔位符 5"/>
+          <p:cNvPr id="970934087" name="頁腳佔位符 5"/>
           <p:cNvSpPr>
             <a:spLocks noGrp="1"/>
           </p:cNvSpPr>
@@ -350,7 +351,7 @@
       </p:sp>
       <p:sp>
         <p:nvSpPr>
-          <p:cNvPr id="859391247" name="幻燈片編號佔位符 6"/>
+          <p:cNvPr id="874119481" name="幻燈片編號佔位符 6"/>
           <p:cNvSpPr>
             <a:spLocks noGrp="1"/>
           </p:cNvSpPr>
@@ -503,7 +504,7 @@
       </p:grpSpPr>
       <p:sp>
         <p:nvSpPr>
-          <p:cNvPr id="386592885" name="幻燈片圖像佔位符 1"/>
+          <p:cNvPr id="1534140398" name="幻燈片圖像佔位符 1"/>
           <p:cNvSpPr>
             <a:spLocks noChangeAspect="1" noGrp="1" noRot="1"/>
           </p:cNvSpPr>
@@ -520,7 +521,7 @@
       </p:sp>
       <p:sp>
         <p:nvSpPr>
-          <p:cNvPr id="1466031300" name="備註 佔位符 2"/>
+          <p:cNvPr id="1073269157" name="備註 佔位符 2"/>
           <p:cNvSpPr>
             <a:spLocks noGrp="1"/>
           </p:cNvSpPr>
@@ -545,7 +546,7 @@
       </p:sp>
       <p:sp>
         <p:nvSpPr>
-          <p:cNvPr id="590390902" name="幻燈片編號佔位符 3"/>
+          <p:cNvPr id="1533868688" name="幻燈片編號佔位符 3"/>
           <p:cNvSpPr>
             <a:spLocks noGrp="1"/>
           </p:cNvSpPr>
@@ -564,6 +565,99 @@
             <a:fld id="{2E6999B8-B6B4-4561-A3CD-BBCDAB9FC9D9}" type="slidenum">
               <a:rPr lang="zh-TW"/>
               <a:t>1</a:t>
+            </a:fld>
+            <a:endParaRPr lang="zh-TW"/>
+          </a:p>
+        </p:txBody>
+      </p:sp>
+    </p:spTree>
+  </p:cSld>
+  <p:clrMapOvr>
+    <a:masterClrMapping/>
+  </p:clrMapOvr>
+</p:notes>
+</file>
+
+<file path=ppt/notesSlides/notesSlide2.xml><?xml version="1.0" encoding="utf-8"?>
+<p:notes xmlns:a="http://schemas.openxmlformats.org/drawingml/2006/main" xmlns:r="http://schemas.openxmlformats.org/officeDocument/2006/relationships" xmlns:p="http://schemas.openxmlformats.org/presentationml/2006/main" xmlns:m="http://schemas.openxmlformats.org/officeDocument/2006/math" xmlns:w="http://schemas.openxmlformats.org/wordprocessingml/2006/main">
+  <p:cSld name="">
+    <p:spTree>
+      <p:nvGrpSpPr>
+        <p:cNvPr id="1" name=""/>
+        <p:cNvGrpSpPr/>
+        <p:nvPr/>
+      </p:nvGrpSpPr>
+      <p:grpSpPr bwMode="auto">
+        <a:xfrm>
+          <a:off x="0" y="0"/>
+          <a:ext cx="0" cy="0"/>
+          <a:chOff x="0" y="0"/>
+          <a:chExt cx="0" cy="0"/>
+        </a:xfrm>
+      </p:grpSpPr>
+      <p:sp>
+        <p:nvSpPr>
+          <p:cNvPr id="796513284" name="幻燈片圖像佔位符 1"/>
+          <p:cNvSpPr>
+            <a:spLocks noChangeAspect="1" noGrp="1" noRot="1"/>
+          </p:cNvSpPr>
+          <p:nvPr>
+            <p:ph type="sldImg"/>
+          </p:nvPr>
+        </p:nvSpPr>
+        <p:spPr bwMode="auto">
+          <a:xfrm>
+            <a:off x="685800" y="1143000"/>
+            <a:ext cx="5486400" cy="3086100"/>
+          </a:xfrm>
+        </p:spPr>
+      </p:sp>
+      <p:sp>
+        <p:nvSpPr>
+          <p:cNvPr id="375056269" name="備註 佔位符 2"/>
+          <p:cNvSpPr>
+            <a:spLocks noGrp="1"/>
+          </p:cNvSpPr>
+          <p:nvPr>
+            <p:ph type="body" idx="1"/>
+          </p:nvPr>
+        </p:nvSpPr>
+        <p:spPr bwMode="auto"/>
+        <p:txBody>
+          <a:bodyPr/>
+          <a:lstStyle/>
+          <a:p>
+            <a:pPr>
+              <a:defRPr/>
+            </a:pPr>
+            <a:endParaRPr lang="zh-TW">
+              <a:latin typeface="Arial"/>
+              <a:cs typeface="Arial"/>
+            </a:endParaRPr>
+          </a:p>
+        </p:txBody>
+      </p:sp>
+      <p:sp>
+        <p:nvSpPr>
+          <p:cNvPr id="2103990503" name="幻燈片編號佔位符 3"/>
+          <p:cNvSpPr>
+            <a:spLocks noGrp="1"/>
+          </p:cNvSpPr>
+          <p:nvPr>
+            <p:ph type="sldNum" sz="quarter" idx="10"/>
+          </p:nvPr>
+        </p:nvSpPr>
+        <p:spPr bwMode="auto"/>
+        <p:txBody>
+          <a:bodyPr/>
+          <a:lstStyle/>
+          <a:p>
+            <a:pPr>
+              <a:defRPr/>
+            </a:pPr>
+            <a:fld id="{D372D718-A77C-2A67-8C52-D6FC66433453}" type="slidenum">
+              <a:rPr lang="zh-TW"/>
+              <a:t/>
             </a:fld>
             <a:endParaRPr lang="zh-TW"/>
           </a:p>
@@ -596,7 +690,7 @@
       </p:grpSpPr>
       <p:sp>
         <p:nvSpPr>
-          <p:cNvPr id="1112799325" name="標題 1"/>
+          <p:cNvPr id="24543568" name="標題 1"/>
           <p:cNvSpPr>
             <a:spLocks noGrp="1"/>
           </p:cNvSpPr>
@@ -631,7 +725,7 @@
       </p:sp>
       <p:sp>
         <p:nvSpPr>
-          <p:cNvPr id="1552835911" name="副標題 2"/>
+          <p:cNvPr id="331785065" name="副標題 2"/>
           <p:cNvSpPr>
             <a:spLocks noGrp="1"/>
           </p:cNvSpPr>
@@ -699,7 +793,7 @@
       </p:sp>
       <p:sp>
         <p:nvSpPr>
-          <p:cNvPr id="818983038" name="日期版面配置區 3"/>
+          <p:cNvPr id="1872253452" name="日期版面配置區 3"/>
           <p:cNvSpPr>
             <a:spLocks noGrp="1"/>
           </p:cNvSpPr>
@@ -725,7 +819,7 @@
       </p:sp>
       <p:sp>
         <p:nvSpPr>
-          <p:cNvPr id="2135804214" name="頁尾版面配置區 4"/>
+          <p:cNvPr id="1427244681" name="頁尾版面配置區 4"/>
           <p:cNvSpPr>
             <a:spLocks noGrp="1"/>
           </p:cNvSpPr>
@@ -747,7 +841,7 @@
       </p:sp>
       <p:sp>
         <p:nvSpPr>
-          <p:cNvPr id="800899566" name="投影片編號版面配置區 5"/>
+          <p:cNvPr id="1562031198" name="投影片編號版面配置區 5"/>
           <p:cNvSpPr>
             <a:spLocks noGrp="1"/>
           </p:cNvSpPr>
@@ -798,7 +892,7 @@
       </p:grpSpPr>
       <p:sp>
         <p:nvSpPr>
-          <p:cNvPr id="1739009053" name="標題 1"/>
+          <p:cNvPr id="1179555422" name="標題 1"/>
           <p:cNvSpPr>
             <a:spLocks noGrp="1"/>
           </p:cNvSpPr>
@@ -824,7 +918,7 @@
       </p:sp>
       <p:sp>
         <p:nvSpPr>
-          <p:cNvPr id="1444000641" name="直排文字版面配置區 2"/>
+          <p:cNvPr id="685648795" name="直排文字版面配置區 2"/>
           <p:cNvSpPr>
             <a:spLocks noGrp="1"/>
           </p:cNvSpPr>
@@ -890,7 +984,7 @@
       </p:sp>
       <p:sp>
         <p:nvSpPr>
-          <p:cNvPr id="1714191902" name="日期版面配置區 3"/>
+          <p:cNvPr id="1688950271" name="日期版面配置區 3"/>
           <p:cNvSpPr>
             <a:spLocks noGrp="1"/>
           </p:cNvSpPr>
@@ -916,7 +1010,7 @@
       </p:sp>
       <p:sp>
         <p:nvSpPr>
-          <p:cNvPr id="1439208921" name="頁尾版面配置區 4"/>
+          <p:cNvPr id="461190665" name="頁尾版面配置區 4"/>
           <p:cNvSpPr>
             <a:spLocks noGrp="1"/>
           </p:cNvSpPr>
@@ -938,7 +1032,7 @@
       </p:sp>
       <p:sp>
         <p:nvSpPr>
-          <p:cNvPr id="31333236" name="投影片編號版面配置區 5"/>
+          <p:cNvPr id="685492397" name="投影片編號版面配置區 5"/>
           <p:cNvSpPr>
             <a:spLocks noGrp="1"/>
           </p:cNvSpPr>
@@ -989,7 +1083,7 @@
       </p:grpSpPr>
       <p:sp>
         <p:nvSpPr>
-          <p:cNvPr id="160981140" name="直排標題 1"/>
+          <p:cNvPr id="1692979907" name="直排標題 1"/>
           <p:cNvSpPr>
             <a:spLocks noGrp="1"/>
           </p:cNvSpPr>
@@ -1020,7 +1114,7 @@
       </p:sp>
       <p:sp>
         <p:nvSpPr>
-          <p:cNvPr id="2082933988" name="直排文字版面配置區 2"/>
+          <p:cNvPr id="600489865" name="直排文字版面配置區 2"/>
           <p:cNvSpPr>
             <a:spLocks noGrp="1"/>
           </p:cNvSpPr>
@@ -1091,7 +1185,7 @@
       </p:sp>
       <p:sp>
         <p:nvSpPr>
-          <p:cNvPr id="1616118107" name="日期版面配置區 3"/>
+          <p:cNvPr id="1735191031" name="日期版面配置區 3"/>
           <p:cNvSpPr>
             <a:spLocks noGrp="1"/>
           </p:cNvSpPr>
@@ -1117,7 +1211,7 @@
       </p:sp>
       <p:sp>
         <p:nvSpPr>
-          <p:cNvPr id="839064081" name="頁尾版面配置區 4"/>
+          <p:cNvPr id="1128598242" name="頁尾版面配置區 4"/>
           <p:cNvSpPr>
             <a:spLocks noGrp="1"/>
           </p:cNvSpPr>
@@ -1139,7 +1233,7 @@
       </p:sp>
       <p:sp>
         <p:nvSpPr>
-          <p:cNvPr id="403258572" name="投影片編號版面配置區 5"/>
+          <p:cNvPr id="217108380" name="投影片編號版面配置區 5"/>
           <p:cNvSpPr>
             <a:spLocks noGrp="1"/>
           </p:cNvSpPr>
@@ -1190,7 +1284,7 @@
       </p:grpSpPr>
       <p:sp>
         <p:nvSpPr>
-          <p:cNvPr id="1726218930" name="標題 1"/>
+          <p:cNvPr id="546135791" name="標題 1"/>
           <p:cNvSpPr>
             <a:spLocks noGrp="1"/>
           </p:cNvSpPr>
@@ -1216,7 +1310,7 @@
       </p:sp>
       <p:sp>
         <p:nvSpPr>
-          <p:cNvPr id="475133027" name="內容版面配置區 2"/>
+          <p:cNvPr id="1645627406" name="內容版面配置區 2"/>
           <p:cNvSpPr>
             <a:spLocks noGrp="1"/>
           </p:cNvSpPr>
@@ -1282,7 +1376,7 @@
       </p:sp>
       <p:sp>
         <p:nvSpPr>
-          <p:cNvPr id="1948537991" name="日期版面配置區 3"/>
+          <p:cNvPr id="168871493" name="日期版面配置區 3"/>
           <p:cNvSpPr>
             <a:spLocks noGrp="1"/>
           </p:cNvSpPr>
@@ -1308,7 +1402,7 @@
       </p:sp>
       <p:sp>
         <p:nvSpPr>
-          <p:cNvPr id="2063208889" name="頁尾版面配置區 4"/>
+          <p:cNvPr id="1774464432" name="頁尾版面配置區 4"/>
           <p:cNvSpPr>
             <a:spLocks noGrp="1"/>
           </p:cNvSpPr>
@@ -1330,7 +1424,7 @@
       </p:sp>
       <p:sp>
         <p:nvSpPr>
-          <p:cNvPr id="1690977950" name="投影片編號版面配置區 5"/>
+          <p:cNvPr id="700798861" name="投影片編號版面配置區 5"/>
           <p:cNvSpPr>
             <a:spLocks noGrp="1"/>
           </p:cNvSpPr>
@@ -1381,7 +1475,7 @@
       </p:grpSpPr>
       <p:sp>
         <p:nvSpPr>
-          <p:cNvPr id="1875634730" name="標題 1"/>
+          <p:cNvPr id="1908056283" name="標題 1"/>
           <p:cNvSpPr>
             <a:spLocks noGrp="1"/>
           </p:cNvSpPr>
@@ -1416,7 +1510,7 @@
       </p:sp>
       <p:sp>
         <p:nvSpPr>
-          <p:cNvPr id="2031193412" name="文字版面配置區 2"/>
+          <p:cNvPr id="1229416752" name="文字版面配置區 2"/>
           <p:cNvSpPr>
             <a:spLocks noGrp="1"/>
           </p:cNvSpPr>
@@ -1538,7 +1632,7 @@
       </p:sp>
       <p:sp>
         <p:nvSpPr>
-          <p:cNvPr id="467836774" name="日期版面配置區 3"/>
+          <p:cNvPr id="2133001039" name="日期版面配置區 3"/>
           <p:cNvSpPr>
             <a:spLocks noGrp="1"/>
           </p:cNvSpPr>
@@ -1564,7 +1658,7 @@
       </p:sp>
       <p:sp>
         <p:nvSpPr>
-          <p:cNvPr id="2091562849" name="頁尾版面配置區 4"/>
+          <p:cNvPr id="1102404691" name="頁尾版面配置區 4"/>
           <p:cNvSpPr>
             <a:spLocks noGrp="1"/>
           </p:cNvSpPr>
@@ -1586,7 +1680,7 @@
       </p:sp>
       <p:sp>
         <p:nvSpPr>
-          <p:cNvPr id="1032080226" name="投影片編號版面配置區 5"/>
+          <p:cNvPr id="151240440" name="投影片編號版面配置區 5"/>
           <p:cNvSpPr>
             <a:spLocks noGrp="1"/>
           </p:cNvSpPr>
@@ -1637,7 +1731,7 @@
       </p:grpSpPr>
       <p:sp>
         <p:nvSpPr>
-          <p:cNvPr id="1049192816" name="標題 1"/>
+          <p:cNvPr id="238819565" name="標題 1"/>
           <p:cNvSpPr>
             <a:spLocks noGrp="1"/>
           </p:cNvSpPr>
@@ -1663,7 +1757,7 @@
       </p:sp>
       <p:sp>
         <p:nvSpPr>
-          <p:cNvPr id="1199558183" name="內容版面配置區 2"/>
+          <p:cNvPr id="1517133060" name="內容版面配置區 2"/>
           <p:cNvSpPr>
             <a:spLocks noGrp="1"/>
           </p:cNvSpPr>
@@ -1734,7 +1828,7 @@
       </p:sp>
       <p:sp>
         <p:nvSpPr>
-          <p:cNvPr id="954982444" name="內容版面配置區 3"/>
+          <p:cNvPr id="1457770850" name="內容版面配置區 3"/>
           <p:cNvSpPr>
             <a:spLocks noGrp="1"/>
           </p:cNvSpPr>
@@ -1805,7 +1899,7 @@
       </p:sp>
       <p:sp>
         <p:nvSpPr>
-          <p:cNvPr id="1655386146" name="日期版面配置區 4"/>
+          <p:cNvPr id="1666359605" name="日期版面配置區 4"/>
           <p:cNvSpPr>
             <a:spLocks noGrp="1"/>
           </p:cNvSpPr>
@@ -1831,7 +1925,7 @@
       </p:sp>
       <p:sp>
         <p:nvSpPr>
-          <p:cNvPr id="330520675" name="頁尾版面配置區 5"/>
+          <p:cNvPr id="1159999559" name="頁尾版面配置區 5"/>
           <p:cNvSpPr>
             <a:spLocks noGrp="1"/>
           </p:cNvSpPr>
@@ -1853,7 +1947,7 @@
       </p:sp>
       <p:sp>
         <p:nvSpPr>
-          <p:cNvPr id="1834465254" name="投影片編號版面配置區 6"/>
+          <p:cNvPr id="970041326" name="投影片編號版面配置區 6"/>
           <p:cNvSpPr>
             <a:spLocks noGrp="1"/>
           </p:cNvSpPr>
@@ -1904,7 +1998,7 @@
       </p:grpSpPr>
       <p:sp>
         <p:nvSpPr>
-          <p:cNvPr id="788599385" name="標題 1"/>
+          <p:cNvPr id="1930303668" name="標題 1"/>
           <p:cNvSpPr>
             <a:spLocks noGrp="1"/>
           </p:cNvSpPr>
@@ -1935,7 +2029,7 @@
       </p:sp>
       <p:sp>
         <p:nvSpPr>
-          <p:cNvPr id="1346394502" name="文字版面配置區 2"/>
+          <p:cNvPr id="2055298707" name="文字版面配置區 2"/>
           <p:cNvSpPr>
             <a:spLocks noGrp="1"/>
           </p:cNvSpPr>
@@ -2003,7 +2097,7 @@
       </p:sp>
       <p:sp>
         <p:nvSpPr>
-          <p:cNvPr id="1951199919" name="內容版面配置區 3"/>
+          <p:cNvPr id="1725342154" name="內容版面配置區 3"/>
           <p:cNvSpPr>
             <a:spLocks noGrp="1"/>
           </p:cNvSpPr>
@@ -2074,7 +2168,7 @@
       </p:sp>
       <p:sp>
         <p:nvSpPr>
-          <p:cNvPr id="2124653064" name="文字版面配置區 4"/>
+          <p:cNvPr id="1296761419" name="文字版面配置區 4"/>
           <p:cNvSpPr>
             <a:spLocks noGrp="1"/>
           </p:cNvSpPr>
@@ -2142,7 +2236,7 @@
       </p:sp>
       <p:sp>
         <p:nvSpPr>
-          <p:cNvPr id="2136044807" name="內容版面配置區 5"/>
+          <p:cNvPr id="1706346017" name="內容版面配置區 5"/>
           <p:cNvSpPr>
             <a:spLocks noGrp="1"/>
           </p:cNvSpPr>
@@ -2213,7 +2307,7 @@
       </p:sp>
       <p:sp>
         <p:nvSpPr>
-          <p:cNvPr id="1279684172" name="日期版面配置區 6"/>
+          <p:cNvPr id="1190652654" name="日期版面配置區 6"/>
           <p:cNvSpPr>
             <a:spLocks noGrp="1"/>
           </p:cNvSpPr>
@@ -2239,7 +2333,7 @@
       </p:sp>
       <p:sp>
         <p:nvSpPr>
-          <p:cNvPr id="395859991" name="頁尾版面配置區 7"/>
+          <p:cNvPr id="1823767109" name="頁尾版面配置區 7"/>
           <p:cNvSpPr>
             <a:spLocks noGrp="1"/>
           </p:cNvSpPr>
@@ -2261,7 +2355,7 @@
       </p:sp>
       <p:sp>
         <p:nvSpPr>
-          <p:cNvPr id="890787553" name="投影片編號版面配置區 8"/>
+          <p:cNvPr id="1199049013" name="投影片編號版面配置區 8"/>
           <p:cNvSpPr>
             <a:spLocks noGrp="1"/>
           </p:cNvSpPr>
@@ -2312,7 +2406,7 @@
       </p:grpSpPr>
       <p:sp>
         <p:nvSpPr>
-          <p:cNvPr id="1719564590" name="標題 1"/>
+          <p:cNvPr id="635950097" name="標題 1"/>
           <p:cNvSpPr>
             <a:spLocks noGrp="1"/>
           </p:cNvSpPr>
@@ -2338,7 +2432,7 @@
       </p:sp>
       <p:sp>
         <p:nvSpPr>
-          <p:cNvPr id="517292144" name="日期版面配置區 2"/>
+          <p:cNvPr id="637103881" name="日期版面配置區 2"/>
           <p:cNvSpPr>
             <a:spLocks noGrp="1"/>
           </p:cNvSpPr>
@@ -2364,7 +2458,7 @@
       </p:sp>
       <p:sp>
         <p:nvSpPr>
-          <p:cNvPr id="1615291250" name="頁尾版面配置區 3"/>
+          <p:cNvPr id="844406560" name="頁尾版面配置區 3"/>
           <p:cNvSpPr>
             <a:spLocks noGrp="1"/>
           </p:cNvSpPr>
@@ -2386,7 +2480,7 @@
       </p:sp>
       <p:sp>
         <p:nvSpPr>
-          <p:cNvPr id="334614729" name="投影片編號版面配置區 4"/>
+          <p:cNvPr id="1848623129" name="投影片編號版面配置區 4"/>
           <p:cNvSpPr>
             <a:spLocks noGrp="1"/>
           </p:cNvSpPr>
@@ -2437,7 +2531,7 @@
       </p:grpSpPr>
       <p:sp>
         <p:nvSpPr>
-          <p:cNvPr id="1464551049" name="日期版面配置區 1"/>
+          <p:cNvPr id="1924852017" name="日期版面配置區 1"/>
           <p:cNvSpPr>
             <a:spLocks noGrp="1"/>
           </p:cNvSpPr>
@@ -2463,7 +2557,7 @@
       </p:sp>
       <p:sp>
         <p:nvSpPr>
-          <p:cNvPr id="1685251006" name="頁尾版面配置區 2"/>
+          <p:cNvPr id="290539222" name="頁尾版面配置區 2"/>
           <p:cNvSpPr>
             <a:spLocks noGrp="1"/>
           </p:cNvSpPr>
@@ -2485,7 +2579,7 @@
       </p:sp>
       <p:sp>
         <p:nvSpPr>
-          <p:cNvPr id="2108913567" name="投影片編號版面配置區 3"/>
+          <p:cNvPr id="2014095860" name="投影片編號版面配置區 3"/>
           <p:cNvSpPr>
             <a:spLocks noGrp="1"/>
           </p:cNvSpPr>
@@ -2536,7 +2630,7 @@
       </p:grpSpPr>
       <p:sp>
         <p:nvSpPr>
-          <p:cNvPr id="782890777" name="標題 1"/>
+          <p:cNvPr id="1632960151" name="標題 1"/>
           <p:cNvSpPr>
             <a:spLocks noGrp="1"/>
           </p:cNvSpPr>
@@ -2571,7 +2665,7 @@
       </p:sp>
       <p:sp>
         <p:nvSpPr>
-          <p:cNvPr id="1513337771" name="內容版面配置區 2"/>
+          <p:cNvPr id="1734870595" name="內容版面配置區 2"/>
           <p:cNvSpPr>
             <a:spLocks noGrp="1"/>
           </p:cNvSpPr>
@@ -2670,7 +2764,7 @@
       </p:sp>
       <p:sp>
         <p:nvSpPr>
-          <p:cNvPr id="1024365739" name="文字版面配置區 3"/>
+          <p:cNvPr id="459122138" name="文字版面配置區 3"/>
           <p:cNvSpPr>
             <a:spLocks noGrp="1"/>
           </p:cNvSpPr>
@@ -2738,7 +2832,7 @@
       </p:sp>
       <p:sp>
         <p:nvSpPr>
-          <p:cNvPr id="884377328" name="日期版面配置區 4"/>
+          <p:cNvPr id="1916925018" name="日期版面配置區 4"/>
           <p:cNvSpPr>
             <a:spLocks noGrp="1"/>
           </p:cNvSpPr>
@@ -2764,7 +2858,7 @@
       </p:sp>
       <p:sp>
         <p:nvSpPr>
-          <p:cNvPr id="1755797107" name="頁尾版面配置區 5"/>
+          <p:cNvPr id="1948239861" name="頁尾版面配置區 5"/>
           <p:cNvSpPr>
             <a:spLocks noGrp="1"/>
           </p:cNvSpPr>
@@ -2786,7 +2880,7 @@
       </p:sp>
       <p:sp>
         <p:nvSpPr>
-          <p:cNvPr id="433870671" name="投影片編號版面配置區 6"/>
+          <p:cNvPr id="1565294193" name="投影片編號版面配置區 6"/>
           <p:cNvSpPr>
             <a:spLocks noGrp="1"/>
           </p:cNvSpPr>
@@ -2837,7 +2931,7 @@
       </p:grpSpPr>
       <p:sp>
         <p:nvSpPr>
-          <p:cNvPr id="166026840" name="標題 1"/>
+          <p:cNvPr id="662083432" name="標題 1"/>
           <p:cNvSpPr>
             <a:spLocks noGrp="1"/>
           </p:cNvSpPr>
@@ -2872,7 +2966,7 @@
       </p:sp>
       <p:sp>
         <p:nvSpPr>
-          <p:cNvPr id="913868702" name="圖片版面配置區 2"/>
+          <p:cNvPr id="1681417805" name="圖片版面配置區 2"/>
           <p:cNvSpPr>
             <a:spLocks noChangeAspect="1" noGrp="1"/>
           </p:cNvSpPr>
@@ -2940,7 +3034,7 @@
       </p:sp>
       <p:sp>
         <p:nvSpPr>
-          <p:cNvPr id="797575748" name="文字版面配置區 3"/>
+          <p:cNvPr id="2092316599" name="文字版面配置區 3"/>
           <p:cNvSpPr>
             <a:spLocks noGrp="1"/>
           </p:cNvSpPr>
@@ -3008,7 +3102,7 @@
       </p:sp>
       <p:sp>
         <p:nvSpPr>
-          <p:cNvPr id="692157188" name="日期版面配置區 4"/>
+          <p:cNvPr id="942189952" name="日期版面配置區 4"/>
           <p:cNvSpPr>
             <a:spLocks noGrp="1"/>
           </p:cNvSpPr>
@@ -3034,7 +3128,7 @@
       </p:sp>
       <p:sp>
         <p:nvSpPr>
-          <p:cNvPr id="1397284697" name="頁尾版面配置區 5"/>
+          <p:cNvPr id="1750829898" name="頁尾版面配置區 5"/>
           <p:cNvSpPr>
             <a:spLocks noGrp="1"/>
           </p:cNvSpPr>
@@ -3056,7 +3150,7 @@
       </p:sp>
       <p:sp>
         <p:nvSpPr>
-          <p:cNvPr id="866567141" name="投影片編號版面配置區 6"/>
+          <p:cNvPr id="192933397" name="投影片編號版面配置區 6"/>
           <p:cNvSpPr>
             <a:spLocks noGrp="1"/>
           </p:cNvSpPr>
@@ -3112,7 +3206,7 @@
       </p:grpSpPr>
       <p:sp>
         <p:nvSpPr>
-          <p:cNvPr id="36130486" name="標題版面配置區 1"/>
+          <p:cNvPr id="88393543" name="標題版面配置區 1"/>
           <p:cNvSpPr>
             <a:spLocks noGrp="1"/>
           </p:cNvSpPr>
@@ -3148,7 +3242,7 @@
       </p:sp>
       <p:sp>
         <p:nvSpPr>
-          <p:cNvPr id="281861644" name="文字版面配置區 2"/>
+          <p:cNvPr id="1796909773" name="文字版面配置區 2"/>
           <p:cNvSpPr>
             <a:spLocks noGrp="1"/>
           </p:cNvSpPr>
@@ -3224,7 +3318,7 @@
       </p:sp>
       <p:sp>
         <p:nvSpPr>
-          <p:cNvPr id="1612083261" name="日期版面配置區 3"/>
+          <p:cNvPr id="1386753934" name="日期版面配置區 3"/>
           <p:cNvSpPr>
             <a:spLocks noGrp="1"/>
           </p:cNvSpPr>
@@ -3268,7 +3362,7 @@
       </p:sp>
       <p:sp>
         <p:nvSpPr>
-          <p:cNvPr id="322551735" name="頁尾版面配置區 4"/>
+          <p:cNvPr id="2027310648" name="頁尾版面配置區 4"/>
           <p:cNvSpPr>
             <a:spLocks noGrp="1"/>
           </p:cNvSpPr>
@@ -3308,7 +3402,7 @@
       </p:sp>
       <p:sp>
         <p:nvSpPr>
-          <p:cNvPr id="1962389294" name="投影片編號版面配置區 5"/>
+          <p:cNvPr id="391975703" name="投影片編號版面配置區 5"/>
           <p:cNvSpPr>
             <a:spLocks noGrp="1"/>
           </p:cNvSpPr>
@@ -3668,7 +3762,7 @@
       </p:grpSpPr>
       <p:pic>
         <p:nvPicPr>
-          <p:cNvPr id="723607493" name=""/>
+          <p:cNvPr id="1671075027" name=""/>
           <p:cNvPicPr>
             <a:picLocks noChangeAspect="1"/>
           </p:cNvPicPr>
@@ -3690,7 +3784,7 @@
       </p:pic>
       <p:sp>
         <p:nvSpPr>
-          <p:cNvPr id="1320339230" name=""/>
+          <p:cNvPr id="178716259" name=""/>
           <p:cNvSpPr/>
           <p:nvPr/>
         </p:nvSpPr>
@@ -3745,7 +3839,7 @@
       </p:sp>
       <p:sp>
         <p:nvSpPr>
-          <p:cNvPr id="1177271237" name=""/>
+          <p:cNvPr id="1017351111" name=""/>
           <p:cNvSpPr/>
           <p:nvPr/>
         </p:nvSpPr>
@@ -3800,7 +3894,7 @@
       </p:sp>
       <p:sp>
         <p:nvSpPr>
-          <p:cNvPr id="735549638" name=""/>
+          <p:cNvPr id="919172035" name=""/>
           <p:cNvSpPr/>
           <p:nvPr/>
         </p:nvSpPr>
@@ -3855,7 +3949,7 @@
       </p:sp>
       <p:sp>
         <p:nvSpPr>
-          <p:cNvPr id="11462743" name=""/>
+          <p:cNvPr id="278170287" name=""/>
           <p:cNvSpPr/>
           <p:nvPr/>
         </p:nvSpPr>
@@ -3910,7 +4004,7 @@
       </p:sp>
       <p:sp>
         <p:nvSpPr>
-          <p:cNvPr id="445630252" name=""/>
+          <p:cNvPr id="1797539234" name=""/>
           <p:cNvSpPr/>
           <p:nvPr/>
         </p:nvSpPr>
@@ -3950,7 +4044,7 @@
       </p:sp>
       <p:sp>
         <p:nvSpPr>
-          <p:cNvPr id="1908471127" name=""/>
+          <p:cNvPr id="1668906256" name=""/>
           <p:cNvSpPr/>
           <p:nvPr/>
         </p:nvSpPr>
@@ -3990,7 +4084,7 @@
       </p:sp>
       <p:sp>
         <p:nvSpPr>
-          <p:cNvPr id="920126210" name=""/>
+          <p:cNvPr id="1925222655" name=""/>
           <p:cNvSpPr/>
           <p:nvPr/>
         </p:nvSpPr>
@@ -4030,7 +4124,7 @@
       </p:sp>
       <p:sp>
         <p:nvSpPr>
-          <p:cNvPr id="1697715499" name=""/>
+          <p:cNvPr id="1347303249" name=""/>
           <p:cNvSpPr txBox="1"/>
           <p:nvPr/>
         </p:nvSpPr>
@@ -4069,7 +4163,7 @@
       </p:sp>
       <p:sp>
         <p:nvSpPr>
-          <p:cNvPr id="545822349" name=""/>
+          <p:cNvPr id="1265480057" name=""/>
           <p:cNvSpPr txBox="1"/>
           <p:nvPr/>
         </p:nvSpPr>
@@ -4108,7 +4202,7 @@
       </p:sp>
       <p:sp>
         <p:nvSpPr>
-          <p:cNvPr id="469264351" name=""/>
+          <p:cNvPr id="2008481424" name=""/>
           <p:cNvSpPr txBox="1"/>
           <p:nvPr/>
         </p:nvSpPr>
@@ -4147,7 +4241,7 @@
       </p:sp>
       <p:cxnSp>
         <p:nvCxnSpPr>
-          <p:cNvPr id="590056152" name=""/>
+          <p:cNvPr id="958097019" name=""/>
           <p:cNvCxnSpPr/>
           <p:nvPr/>
         </p:nvCxnSpPr>
@@ -4187,15 +4281,15 @@
       </p:cxnSp>
       <p:cxnSp>
         <p:nvCxnSpPr>
-          <p:cNvPr id="1504002777" name=""/>
+          <p:cNvPr id="1712023674" name=""/>
           <p:cNvCxnSpPr>
-            <a:stCxn id="1908471127" idx="2"/>
-            <a:endCxn id="545822349" idx="0"/>
+            <a:stCxn id="1668906256" idx="2"/>
+            <a:endCxn id="1265480057" idx="0"/>
           </p:cNvCxnSpPr>
           <p:nvPr/>
         </p:nvCxnSpPr>
         <p:spPr bwMode="auto">
-          <a:xfrm rot="5399978" flipH="0" flipV="0">
+          <a:xfrm rot="5399976" flipH="0" flipV="0">
             <a:off x="8812877" y="4263700"/>
             <a:ext cx="1250301" cy="0"/>
           </a:xfrm>
@@ -4230,15 +4324,15 @@
       </p:cxnSp>
       <p:cxnSp>
         <p:nvCxnSpPr>
-          <p:cNvPr id="1432588146" name=""/>
+          <p:cNvPr id="85203424" name=""/>
           <p:cNvCxnSpPr>
-            <a:stCxn id="920126210" idx="2"/>
-            <a:endCxn id="469264351" idx="0"/>
+            <a:stCxn id="1925222655" idx="2"/>
+            <a:endCxn id="2008481424" idx="0"/>
           </p:cNvCxnSpPr>
           <p:nvPr/>
         </p:nvCxnSpPr>
         <p:spPr bwMode="auto">
-          <a:xfrm rot="5399978" flipH="0" flipV="0">
+          <a:xfrm rot="5399976" flipH="0" flipV="0">
             <a:off x="9790777" y="4263700"/>
             <a:ext cx="1250301" cy="0"/>
           </a:xfrm>
@@ -4273,7 +4367,7 @@
       </p:cxnSp>
       <p:sp>
         <p:nvSpPr>
-          <p:cNvPr id="961210310" name=""/>
+          <p:cNvPr id="376212760" name=""/>
           <p:cNvSpPr/>
           <p:nvPr/>
         </p:nvSpPr>
@@ -4313,10 +4407,10 @@
       </p:sp>
       <p:cxnSp>
         <p:nvCxnSpPr>
-          <p:cNvPr id="2138245457" name=""/>
+          <p:cNvPr id="301560043" name=""/>
           <p:cNvCxnSpPr>
-            <a:stCxn id="961210310" idx="0"/>
-            <a:endCxn id="883437392" idx="2"/>
+            <a:stCxn id="376212760" idx="0"/>
+            <a:endCxn id="348403763" idx="2"/>
           </p:cNvCxnSpPr>
           <p:nvPr/>
         </p:nvCxnSpPr>
@@ -4356,7 +4450,7 @@
       </p:cxnSp>
       <p:sp>
         <p:nvSpPr>
-          <p:cNvPr id="883437392" name=""/>
+          <p:cNvPr id="348403763" name=""/>
           <p:cNvSpPr txBox="1"/>
           <p:nvPr/>
         </p:nvSpPr>
@@ -4395,7 +4489,7 @@
       </p:sp>
       <p:sp>
         <p:nvSpPr>
-          <p:cNvPr id="905864838" name=""/>
+          <p:cNvPr id="619724825" name=""/>
           <p:cNvSpPr/>
           <p:nvPr/>
         </p:nvSpPr>
@@ -4435,15 +4529,15 @@
       </p:sp>
       <p:cxnSp>
         <p:nvCxnSpPr>
-          <p:cNvPr id="1691115006" name=""/>
+          <p:cNvPr id="1482709342" name=""/>
           <p:cNvCxnSpPr>
-            <a:stCxn id="905864838" idx="2"/>
-            <a:endCxn id="1434873476" idx="0"/>
+            <a:stCxn id="619724825" idx="2"/>
+            <a:endCxn id="1961340473" idx="0"/>
           </p:cNvCxnSpPr>
           <p:nvPr/>
         </p:nvCxnSpPr>
         <p:spPr bwMode="auto">
-          <a:xfrm rot="5399978" flipH="0" flipV="0">
+          <a:xfrm rot="5399976" flipH="0" flipV="0">
             <a:off x="1652458" y="4497856"/>
             <a:ext cx="781989" cy="0"/>
           </a:xfrm>
@@ -4478,7 +4572,7 @@
       </p:cxnSp>
       <p:sp>
         <p:nvSpPr>
-          <p:cNvPr id="1434873476" name=""/>
+          <p:cNvPr id="1961340473" name=""/>
           <p:cNvSpPr txBox="1"/>
           <p:nvPr/>
         </p:nvSpPr>
@@ -4517,7 +4611,7 @@
       </p:sp>
       <p:sp>
         <p:nvSpPr>
-          <p:cNvPr id="504629082" name=""/>
+          <p:cNvPr id="357986976" name=""/>
           <p:cNvSpPr/>
           <p:nvPr/>
         </p:nvSpPr>
@@ -4557,7 +4651,7 @@
       </p:sp>
       <p:cxnSp>
         <p:nvCxnSpPr>
-          <p:cNvPr id="502770817" name=""/>
+          <p:cNvPr id="1529552828" name=""/>
           <p:cNvCxnSpPr/>
           <p:nvPr/>
         </p:nvCxnSpPr>
@@ -4597,7 +4691,7 @@
       </p:cxnSp>
       <p:sp>
         <p:nvSpPr>
-          <p:cNvPr id="774191666" name=""/>
+          <p:cNvPr id="1803521738" name=""/>
           <p:cNvSpPr txBox="1"/>
           <p:nvPr/>
         </p:nvSpPr>
@@ -4636,7 +4730,7 @@
       </p:sp>
       <p:sp>
         <p:nvSpPr>
-          <p:cNvPr id="1769101484" name=""/>
+          <p:cNvPr id="688853" name=""/>
           <p:cNvSpPr/>
           <p:nvPr/>
         </p:nvSpPr>
@@ -4676,12 +4770,12 @@
       </p:sp>
       <p:cxnSp>
         <p:nvCxnSpPr>
-          <p:cNvPr id="1230926851" name=""/>
+          <p:cNvPr id="53082005" name=""/>
           <p:cNvCxnSpPr/>
           <p:nvPr/>
         </p:nvCxnSpPr>
         <p:spPr bwMode="auto">
-          <a:xfrm rot="5399978" flipH="0" flipV="0">
+          <a:xfrm rot="5399976" flipH="0" flipV="0">
             <a:off x="2612895" y="4497856"/>
             <a:ext cx="781989" cy="0"/>
           </a:xfrm>
@@ -4716,13 +4810,13 @@
       </p:cxnSp>
       <p:sp>
         <p:nvSpPr>
-          <p:cNvPr id="1082767365" name=""/>
+          <p:cNvPr id="356228055" name=""/>
           <p:cNvSpPr txBox="1"/>
           <p:nvPr/>
         </p:nvSpPr>
         <p:spPr bwMode="auto">
           <a:xfrm rot="0" flipH="0" flipV="0">
-            <a:off x="2734292" y="4888851"/>
+            <a:off x="2734291" y="4888851"/>
             <a:ext cx="539196" cy="305159"/>
           </a:xfrm>
           <a:prstGeom prst="rect">
@@ -4752,6 +4846,1326 @@
             </a:endParaRPr>
           </a:p>
         </p:txBody>
+      </p:sp>
+    </p:spTree>
+  </p:cSld>
+  <p:clrMapOvr>
+    <a:masterClrMapping/>
+  </p:clrMapOvr>
+  <mc:AlternateContent xmlns:mc="http://schemas.openxmlformats.org/markup-compatibility/2006">
+    <mc:Choice xmlns:p159="http://schemas.microsoft.com/office/powerpoint/2015/09/main" xmlns:p14="http://schemas.microsoft.com/office/powerpoint/2010/main" Requires="p159">
+      <p:transition p14:dur="2000" advClick="1"/>
+    </mc:Choice>
+    <mc:Fallback>
+      <p:transition advClick="1"/>
+    </mc:Fallback>
+  </mc:AlternateContent>
+</p:sld>
+</file>
+
+<file path=ppt/slides/slide2.xml><?xml version="1.0" encoding="utf-8"?>
+<p:sld xmlns:a="http://schemas.openxmlformats.org/drawingml/2006/main" xmlns:r="http://schemas.openxmlformats.org/officeDocument/2006/relationships" xmlns:p="http://schemas.openxmlformats.org/presentationml/2006/main" xmlns:m="http://schemas.openxmlformats.org/officeDocument/2006/math" xmlns:w="http://schemas.openxmlformats.org/wordprocessingml/2006/main" xmlns:mc="http://schemas.openxmlformats.org/markup-compatibility/2006" showMasterPhAnim="0" showMasterSp="1" show="1">
+  <p:cSld name="">
+    <p:spTree>
+      <p:nvGrpSpPr>
+        <p:cNvPr id="1" name=""/>
+        <p:cNvGrpSpPr/>
+        <p:nvPr/>
+      </p:nvGrpSpPr>
+      <p:grpSpPr bwMode="auto">
+        <a:xfrm>
+          <a:off x="0" y="0"/>
+          <a:ext cx="0" cy="0"/>
+          <a:chOff x="0" y="0"/>
+          <a:chExt cx="0" cy="0"/>
+        </a:xfrm>
+      </p:grpSpPr>
+      <p:pic>
+        <p:nvPicPr>
+          <p:cNvPr id="829380726" name=""/>
+          <p:cNvPicPr>
+            <a:picLocks noChangeAspect="1"/>
+          </p:cNvPicPr>
+          <p:nvPr/>
+        </p:nvPicPr>
+        <p:blipFill>
+          <a:blip r:embed="rId3"/>
+          <a:stretch/>
+        </p:blipFill>
+        <p:spPr bwMode="auto">
+          <a:xfrm>
+            <a:off x="567229" y="1639134"/>
+            <a:ext cx="10725148" cy="3105148"/>
+          </a:xfrm>
+          <a:prstGeom prst="rect">
+            <a:avLst/>
+          </a:prstGeom>
+        </p:spPr>
+      </p:pic>
+      <p:sp>
+        <p:nvSpPr>
+          <p:cNvPr id="2076424652" name=""/>
+          <p:cNvSpPr/>
+          <p:nvPr/>
+        </p:nvSpPr>
+        <p:spPr bwMode="auto">
+          <a:xfrm rot="0" flipH="0" flipV="0">
+            <a:off x="9726952" y="2762248"/>
+            <a:ext cx="412749" cy="419098"/>
+          </a:xfrm>
+          <a:prstGeom prst="flowChartAlternateProcess">
+            <a:avLst/>
+          </a:prstGeom>
+          <a:noFill/>
+          <a:ln w="38099" cap="flat" cmpd="sng" algn="ctr">
+            <a:solidFill>
+              <a:srgbClr val="FF0000"/>
+            </a:solidFill>
+            <a:prstDash val="solid"/>
+            <a:miter lim="800000"/>
+          </a:ln>
+        </p:spPr>
+        <p:style>
+          <a:lnRef idx="2">
+            <a:schemeClr val="accent1">
+              <a:shade val="50000"/>
+            </a:schemeClr>
+          </a:lnRef>
+          <a:fillRef idx="1">
+            <a:schemeClr val="accent1"/>
+          </a:fillRef>
+          <a:effectRef idx="0">
+            <a:schemeClr val="accent1"/>
+          </a:effectRef>
+          <a:fontRef idx="minor">
+            <a:schemeClr val="lt1"/>
+          </a:fontRef>
+        </p:style>
+      </p:sp>
+      <p:sp>
+        <p:nvSpPr>
+          <p:cNvPr id="755570470" name=""/>
+          <p:cNvSpPr/>
+          <p:nvPr/>
+        </p:nvSpPr>
+        <p:spPr bwMode="auto">
+          <a:xfrm rot="0" flipH="0" flipV="0">
+            <a:off x="9231652" y="3219448"/>
+            <a:ext cx="412749" cy="419098"/>
+          </a:xfrm>
+          <a:prstGeom prst="flowChartAlternateProcess">
+            <a:avLst/>
+          </a:prstGeom>
+          <a:noFill/>
+          <a:ln w="38099" cap="flat" cmpd="sng" algn="ctr">
+            <a:solidFill>
+              <a:srgbClr val="FF0000"/>
+            </a:solidFill>
+            <a:prstDash val="solid"/>
+            <a:miter lim="800000"/>
+          </a:ln>
+        </p:spPr>
+        <p:style>
+          <a:lnRef idx="2">
+            <a:schemeClr val="accent1">
+              <a:shade val="50000"/>
+            </a:schemeClr>
+          </a:lnRef>
+          <a:fillRef idx="1">
+            <a:schemeClr val="accent1"/>
+          </a:fillRef>
+          <a:effectRef idx="0">
+            <a:schemeClr val="accent1"/>
+          </a:effectRef>
+          <a:fontRef idx="minor">
+            <a:schemeClr val="lt1"/>
+          </a:fontRef>
+        </p:style>
+      </p:sp>
+      <p:sp>
+        <p:nvSpPr>
+          <p:cNvPr id="2091923671" name=""/>
+          <p:cNvSpPr/>
+          <p:nvPr/>
+        </p:nvSpPr>
+        <p:spPr bwMode="auto">
+          <a:xfrm rot="0" flipH="0" flipV="0">
+            <a:off x="10209552" y="3219448"/>
+            <a:ext cx="412749" cy="419098"/>
+          </a:xfrm>
+          <a:prstGeom prst="flowChartAlternateProcess">
+            <a:avLst/>
+          </a:prstGeom>
+          <a:noFill/>
+          <a:ln w="38099" cap="flat" cmpd="sng" algn="ctr">
+            <a:solidFill>
+              <a:srgbClr val="FF0000"/>
+            </a:solidFill>
+            <a:prstDash val="solid"/>
+            <a:miter lim="800000"/>
+          </a:ln>
+        </p:spPr>
+        <p:style>
+          <a:lnRef idx="2">
+            <a:schemeClr val="accent1">
+              <a:shade val="50000"/>
+            </a:schemeClr>
+          </a:lnRef>
+          <a:fillRef idx="1">
+            <a:schemeClr val="accent1"/>
+          </a:fillRef>
+          <a:effectRef idx="0">
+            <a:schemeClr val="accent1"/>
+          </a:effectRef>
+          <a:fontRef idx="minor">
+            <a:schemeClr val="lt1"/>
+          </a:fontRef>
+        </p:style>
+      </p:sp>
+      <p:sp>
+        <p:nvSpPr>
+          <p:cNvPr id="932485860" name=""/>
+          <p:cNvSpPr txBox="1"/>
+          <p:nvPr/>
+        </p:nvSpPr>
+        <p:spPr bwMode="auto">
+          <a:xfrm rot="0" flipH="0" flipV="0">
+            <a:off x="9663728" y="1238248"/>
+            <a:ext cx="539195" cy="305158"/>
+          </a:xfrm>
+          <a:prstGeom prst="rect">
+            <a:avLst/>
+          </a:prstGeom>
+          <a:noFill/>
+        </p:spPr>
+        <p:txBody>
+          <a:bodyPr vertOverflow="overflow" horzOverflow="overflow" vert="horz" wrap="none" lIns="91440" tIns="45720" rIns="91440" bIns="45720" numCol="1" spcCol="0" rtlCol="0" fromWordArt="0" anchor="t" anchorCtr="0" forceAA="0" upright="0" compatLnSpc="0">
+            <a:spAutoFit/>
+          </a:bodyPr>
+          <a:p>
+            <a:pPr>
+              <a:defRPr/>
+            </a:pPr>
+            <a:r>
+              <a:rPr sz="1400">
+                <a:latin typeface="GenKiGothic2 TC M"/>
+                <a:ea typeface="GenKiGothic2 TC M"/>
+                <a:cs typeface="GenKiGothic2 TC M"/>
+              </a:rPr>
+              <a:t>向前</a:t>
+            </a:r>
+            <a:endParaRPr sz="1400">
+              <a:latin typeface="GenKiGothic2 TC M"/>
+              <a:cs typeface="GenKiGothic2 TC M"/>
+            </a:endParaRPr>
+          </a:p>
+        </p:txBody>
+      </p:sp>
+      <p:sp>
+        <p:nvSpPr>
+          <p:cNvPr id="134872478" name=""/>
+          <p:cNvSpPr txBox="1"/>
+          <p:nvPr/>
+        </p:nvSpPr>
+        <p:spPr bwMode="auto">
+          <a:xfrm rot="0" flipH="0" flipV="0">
+            <a:off x="9168428" y="4888850"/>
+            <a:ext cx="539195" cy="305158"/>
+          </a:xfrm>
+          <a:prstGeom prst="rect">
+            <a:avLst/>
+          </a:prstGeom>
+          <a:noFill/>
+        </p:spPr>
+        <p:txBody>
+          <a:bodyPr vertOverflow="overflow" horzOverflow="overflow" vert="horz" wrap="none" lIns="91440" tIns="45720" rIns="91440" bIns="45720" numCol="1" spcCol="0" rtlCol="0" fromWordArt="0" anchor="t" anchorCtr="0" forceAA="0" upright="0" compatLnSpc="0">
+            <a:spAutoFit/>
+          </a:bodyPr>
+          <a:p>
+            <a:pPr>
+              <a:defRPr/>
+            </a:pPr>
+            <a:r>
+              <a:rPr sz="1400">
+                <a:latin typeface="GenKiGothic2 TC M"/>
+                <a:ea typeface="GenKiGothic2 TC M"/>
+                <a:cs typeface="GenKiGothic2 TC M"/>
+              </a:rPr>
+              <a:t>向左</a:t>
+            </a:r>
+            <a:endParaRPr sz="1400">
+              <a:latin typeface="GenKiGothic2 TC M"/>
+              <a:cs typeface="GenKiGothic2 TC M"/>
+            </a:endParaRPr>
+          </a:p>
+        </p:txBody>
+      </p:sp>
+      <p:sp>
+        <p:nvSpPr>
+          <p:cNvPr id="329722767" name=""/>
+          <p:cNvSpPr txBox="1"/>
+          <p:nvPr/>
+        </p:nvSpPr>
+        <p:spPr bwMode="auto">
+          <a:xfrm rot="0" flipH="0" flipV="0">
+            <a:off x="10146328" y="4888850"/>
+            <a:ext cx="539195" cy="305158"/>
+          </a:xfrm>
+          <a:prstGeom prst="rect">
+            <a:avLst/>
+          </a:prstGeom>
+          <a:noFill/>
+        </p:spPr>
+        <p:txBody>
+          <a:bodyPr vertOverflow="overflow" horzOverflow="overflow" vert="horz" wrap="none" lIns="91440" tIns="45720" rIns="91440" bIns="45720" numCol="1" spcCol="0" rtlCol="0" fromWordArt="0" anchor="t" anchorCtr="0" forceAA="0" upright="0" compatLnSpc="0">
+            <a:spAutoFit/>
+          </a:bodyPr>
+          <a:p>
+            <a:pPr>
+              <a:defRPr/>
+            </a:pPr>
+            <a:r>
+              <a:rPr sz="1400">
+                <a:latin typeface="GenKiGothic2 TC M"/>
+                <a:ea typeface="GenKiGothic2 TC M"/>
+                <a:cs typeface="GenKiGothic2 TC M"/>
+              </a:rPr>
+              <a:t>向右</a:t>
+            </a:r>
+            <a:endParaRPr sz="1400">
+              <a:latin typeface="GenKiGothic2 TC M"/>
+              <a:cs typeface="GenKiGothic2 TC M"/>
+            </a:endParaRPr>
+          </a:p>
+        </p:txBody>
+      </p:sp>
+      <p:cxnSp>
+        <p:nvCxnSpPr>
+          <p:cNvPr id="10002587" name=""/>
+          <p:cNvCxnSpPr/>
+          <p:nvPr/>
+        </p:nvCxnSpPr>
+        <p:spPr bwMode="auto">
+          <a:xfrm rot="16199932" flipH="0" flipV="0">
+            <a:off x="9324000" y="2152800"/>
+            <a:ext cx="1218838" cy="0"/>
+          </a:xfrm>
+          <a:prstGeom prst="line">
+            <a:avLst/>
+          </a:prstGeom>
+          <a:ln w="38099" cap="flat" cmpd="sng" algn="ctr">
+            <a:solidFill>
+              <a:srgbClr val="FF0000"/>
+            </a:solidFill>
+            <a:prstDash val="solid"/>
+            <a:miter lim="800000"/>
+            <a:tailEnd type="triangle" w="med" len="med"/>
+          </a:ln>
+        </p:spPr>
+        <p:style>
+          <a:lnRef idx="1">
+            <a:schemeClr val="accent1">
+              <a:shade val="50000"/>
+            </a:schemeClr>
+          </a:lnRef>
+          <a:fillRef idx="0">
+            <a:schemeClr val="accent1"/>
+          </a:fillRef>
+          <a:effectRef idx="0">
+            <a:schemeClr val="accent1"/>
+          </a:effectRef>
+          <a:fontRef idx="minor">
+            <a:schemeClr val="tx1"/>
+          </a:fontRef>
+        </p:style>
+      </p:cxnSp>
+      <p:cxnSp>
+        <p:nvCxnSpPr>
+          <p:cNvPr id="1562860082" name=""/>
+          <p:cNvCxnSpPr>
+            <a:stCxn id="755570470" idx="2"/>
+            <a:endCxn id="134872478" idx="0"/>
+          </p:cNvCxnSpPr>
+          <p:nvPr/>
+        </p:nvCxnSpPr>
+        <p:spPr bwMode="auto">
+          <a:xfrm rot="5399942" flipH="0" flipV="0">
+            <a:off x="8812876" y="4263699"/>
+            <a:ext cx="1250300" cy="0"/>
+          </a:xfrm>
+          <a:prstGeom prst="line">
+            <a:avLst/>
+          </a:prstGeom>
+          <a:ln w="38099" cap="flat" cmpd="sng" algn="ctr">
+            <a:solidFill>
+              <a:srgbClr val="FF0000"/>
+            </a:solidFill>
+            <a:prstDash val="solid"/>
+            <a:miter lim="800000"/>
+            <a:tailEnd type="triangle" w="med" len="med"/>
+          </a:ln>
+        </p:spPr>
+        <p:style>
+          <a:lnRef idx="1">
+            <a:schemeClr val="accent1">
+              <a:shade val="50000"/>
+            </a:schemeClr>
+          </a:lnRef>
+          <a:fillRef idx="0">
+            <a:schemeClr val="accent1"/>
+          </a:fillRef>
+          <a:effectRef idx="0">
+            <a:schemeClr val="accent1"/>
+          </a:effectRef>
+          <a:fontRef idx="minor">
+            <a:schemeClr val="tx1"/>
+          </a:fontRef>
+        </p:style>
+      </p:cxnSp>
+      <p:cxnSp>
+        <p:nvCxnSpPr>
+          <p:cNvPr id="1381449563" name=""/>
+          <p:cNvCxnSpPr>
+            <a:stCxn id="2091923671" idx="2"/>
+            <a:endCxn id="329722767" idx="0"/>
+          </p:cNvCxnSpPr>
+          <p:nvPr/>
+        </p:nvCxnSpPr>
+        <p:spPr bwMode="auto">
+          <a:xfrm rot="5399942" flipH="0" flipV="0">
+            <a:off x="9790776" y="4263699"/>
+            <a:ext cx="1250300" cy="0"/>
+          </a:xfrm>
+          <a:prstGeom prst="line">
+            <a:avLst/>
+          </a:prstGeom>
+          <a:ln w="38099" cap="flat" cmpd="sng" algn="ctr">
+            <a:solidFill>
+              <a:srgbClr val="FF0000"/>
+            </a:solidFill>
+            <a:prstDash val="solid"/>
+            <a:miter lim="800000"/>
+            <a:tailEnd type="triangle" w="med" len="med"/>
+          </a:ln>
+        </p:spPr>
+        <p:style>
+          <a:lnRef idx="1">
+            <a:schemeClr val="accent1">
+              <a:shade val="50000"/>
+            </a:schemeClr>
+          </a:lnRef>
+          <a:fillRef idx="0">
+            <a:schemeClr val="accent1"/>
+          </a:fillRef>
+          <a:effectRef idx="0">
+            <a:schemeClr val="accent1"/>
+          </a:effectRef>
+          <a:fontRef idx="minor">
+            <a:schemeClr val="tx1"/>
+          </a:fontRef>
+        </p:style>
+      </p:cxnSp>
+      <p:sp>
+        <p:nvSpPr>
+          <p:cNvPr id="59093787" name=""/>
+          <p:cNvSpPr/>
+          <p:nvPr/>
+        </p:nvSpPr>
+        <p:spPr bwMode="auto">
+          <a:xfrm rot="0" flipH="0" flipV="0">
+            <a:off x="1238589" y="2285998"/>
+            <a:ext cx="4229734" cy="419098"/>
+          </a:xfrm>
+          <a:prstGeom prst="flowChartAlternateProcess">
+            <a:avLst/>
+          </a:prstGeom>
+          <a:noFill/>
+          <a:ln w="38099" cap="flat" cmpd="sng" algn="ctr">
+            <a:solidFill>
+              <a:srgbClr val="FF0000"/>
+            </a:solidFill>
+            <a:prstDash val="solid"/>
+            <a:miter lim="800000"/>
+          </a:ln>
+        </p:spPr>
+        <p:style>
+          <a:lnRef idx="2">
+            <a:schemeClr val="accent1">
+              <a:shade val="50000"/>
+            </a:schemeClr>
+          </a:lnRef>
+          <a:fillRef idx="1">
+            <a:schemeClr val="accent1"/>
+          </a:fillRef>
+          <a:effectRef idx="0">
+            <a:schemeClr val="accent1"/>
+          </a:effectRef>
+          <a:fontRef idx="minor">
+            <a:schemeClr val="lt1"/>
+          </a:fontRef>
+        </p:style>
+      </p:sp>
+      <p:cxnSp>
+        <p:nvCxnSpPr>
+          <p:cNvPr id="782527959" name=""/>
+          <p:cNvCxnSpPr>
+            <a:stCxn id="59093787" idx="0"/>
+            <a:endCxn id="476607363" idx="2"/>
+          </p:cNvCxnSpPr>
+          <p:nvPr/>
+        </p:nvCxnSpPr>
+        <p:spPr bwMode="auto">
+          <a:xfrm rot="16199969" flipH="0" flipV="1">
+            <a:off x="2982162" y="1914703"/>
+            <a:ext cx="742590" cy="0"/>
+          </a:xfrm>
+          <a:prstGeom prst="line">
+            <a:avLst/>
+          </a:prstGeom>
+          <a:ln w="38099" cap="flat" cmpd="sng" algn="ctr">
+            <a:solidFill>
+              <a:srgbClr val="FF0000"/>
+            </a:solidFill>
+            <a:prstDash val="solid"/>
+            <a:miter lim="800000"/>
+            <a:tailEnd type="triangle" w="med" len="med"/>
+          </a:ln>
+        </p:spPr>
+        <p:style>
+          <a:lnRef idx="1">
+            <a:schemeClr val="accent1">
+              <a:shade val="50000"/>
+            </a:schemeClr>
+          </a:lnRef>
+          <a:fillRef idx="0">
+            <a:schemeClr val="accent1"/>
+          </a:fillRef>
+          <a:effectRef idx="0">
+            <a:schemeClr val="accent1"/>
+          </a:effectRef>
+          <a:fontRef idx="minor">
+            <a:schemeClr val="tx1"/>
+          </a:fontRef>
+        </p:style>
+      </p:cxnSp>
+      <p:sp>
+        <p:nvSpPr>
+          <p:cNvPr id="1906863393" name=""/>
+          <p:cNvSpPr txBox="1"/>
+          <p:nvPr/>
+        </p:nvSpPr>
+        <p:spPr bwMode="auto">
+          <a:xfrm rot="0" flipH="0" flipV="0">
+            <a:off x="1797389" y="4945820"/>
+            <a:ext cx="539195" cy="305158"/>
+          </a:xfrm>
+          <a:prstGeom prst="rect">
+            <a:avLst/>
+          </a:prstGeom>
+          <a:noFill/>
+        </p:spPr>
+        <p:txBody>
+          <a:bodyPr vertOverflow="overflow" horzOverflow="overflow" vert="horz" wrap="none" lIns="91440" tIns="45720" rIns="91440" bIns="45720" numCol="1" spcCol="0" rtlCol="0" fromWordArt="0" anchor="t" anchorCtr="0" forceAA="0" upright="0" compatLnSpc="0">
+            <a:spAutoFit/>
+          </a:bodyPr>
+          <a:p>
+            <a:pPr>
+              <a:defRPr/>
+            </a:pPr>
+            <a:r>
+              <a:rPr sz="1400">
+                <a:latin typeface="GenKiGothic2 TC M"/>
+                <a:ea typeface="GenKiGothic2 TC M"/>
+                <a:cs typeface="GenKiGothic2 TC M"/>
+              </a:rPr>
+              <a:t>抬頭</a:t>
+            </a:r>
+            <a:endParaRPr sz="1400">
+              <a:latin typeface="GenKiGothic2 TC M"/>
+              <a:cs typeface="GenKiGothic2 TC M"/>
+            </a:endParaRPr>
+          </a:p>
+        </p:txBody>
+      </p:sp>
+      <p:sp>
+        <p:nvSpPr>
+          <p:cNvPr id="1833729406" name=""/>
+          <p:cNvSpPr/>
+          <p:nvPr/>
+        </p:nvSpPr>
+        <p:spPr bwMode="auto">
+          <a:xfrm rot="0" flipH="0" flipV="0">
+            <a:off x="1837077" y="3687761"/>
+            <a:ext cx="412749" cy="419098"/>
+          </a:xfrm>
+          <a:prstGeom prst="flowChartAlternateProcess">
+            <a:avLst/>
+          </a:prstGeom>
+          <a:noFill/>
+          <a:ln w="38099" cap="flat" cmpd="sng" algn="ctr">
+            <a:solidFill>
+              <a:srgbClr val="FF0000"/>
+            </a:solidFill>
+            <a:prstDash val="solid"/>
+            <a:miter lim="800000"/>
+          </a:ln>
+        </p:spPr>
+        <p:style>
+          <a:lnRef idx="2">
+            <a:schemeClr val="accent1">
+              <a:shade val="50000"/>
+            </a:schemeClr>
+          </a:lnRef>
+          <a:fillRef idx="1">
+            <a:schemeClr val="accent1"/>
+          </a:fillRef>
+          <a:effectRef idx="0">
+            <a:schemeClr val="accent1"/>
+          </a:effectRef>
+          <a:fontRef idx="minor">
+            <a:schemeClr val="lt1"/>
+          </a:fontRef>
+        </p:style>
+      </p:sp>
+      <p:cxnSp>
+        <p:nvCxnSpPr>
+          <p:cNvPr id="1864149644" name=""/>
+          <p:cNvCxnSpPr>
+            <a:stCxn id="1833729406" idx="2"/>
+          </p:cNvCxnSpPr>
+          <p:nvPr/>
+        </p:nvCxnSpPr>
+        <p:spPr bwMode="auto">
+          <a:xfrm rot="5399976" flipH="0" flipV="1">
+            <a:off x="1686500" y="4470399"/>
+            <a:ext cx="727076" cy="0"/>
+          </a:xfrm>
+          <a:prstGeom prst="line">
+            <a:avLst/>
+          </a:prstGeom>
+          <a:ln w="38099" cap="flat" cmpd="sng" algn="ctr">
+            <a:solidFill>
+              <a:srgbClr val="FF0000"/>
+            </a:solidFill>
+            <a:prstDash val="solid"/>
+            <a:miter lim="800000"/>
+            <a:tailEnd type="triangle" w="med" len="med"/>
+          </a:ln>
+        </p:spPr>
+        <p:style>
+          <a:lnRef idx="1">
+            <a:schemeClr val="accent1">
+              <a:shade val="50000"/>
+            </a:schemeClr>
+          </a:lnRef>
+          <a:fillRef idx="0">
+            <a:schemeClr val="accent1"/>
+          </a:fillRef>
+          <a:effectRef idx="0">
+            <a:schemeClr val="accent1"/>
+          </a:effectRef>
+          <a:fontRef idx="minor">
+            <a:schemeClr val="tx1"/>
+          </a:fontRef>
+        </p:style>
+      </p:cxnSp>
+      <p:sp>
+        <p:nvSpPr>
+          <p:cNvPr id="881534263" name=""/>
+          <p:cNvSpPr txBox="1"/>
+          <p:nvPr/>
+        </p:nvSpPr>
+        <p:spPr bwMode="auto">
+          <a:xfrm rot="0" flipH="0" flipV="0">
+            <a:off x="2036068" y="5414133"/>
+            <a:ext cx="539195" cy="305158"/>
+          </a:xfrm>
+          <a:prstGeom prst="rect">
+            <a:avLst/>
+          </a:prstGeom>
+          <a:noFill/>
+        </p:spPr>
+        <p:txBody>
+          <a:bodyPr vertOverflow="overflow" horzOverflow="overflow" vert="horz" wrap="none" lIns="91440" tIns="45720" rIns="91440" bIns="45720" numCol="1" spcCol="0" rtlCol="0" fromWordArt="0" anchor="t" anchorCtr="0" forceAA="0" upright="0" compatLnSpc="0">
+            <a:spAutoFit/>
+          </a:bodyPr>
+          <a:p>
+            <a:pPr>
+              <a:defRPr/>
+            </a:pPr>
+            <a:r>
+              <a:rPr sz="1400">
+                <a:latin typeface="GenKiGothic2 TC M"/>
+                <a:ea typeface="GenKiGothic2 TC M"/>
+                <a:cs typeface="GenKiGothic2 TC M"/>
+              </a:rPr>
+              <a:t>低頭</a:t>
+            </a:r>
+            <a:endParaRPr sz="1400">
+              <a:latin typeface="GenKiGothic2 TC M"/>
+              <a:cs typeface="GenKiGothic2 TC M"/>
+            </a:endParaRPr>
+          </a:p>
+        </p:txBody>
+      </p:sp>
+      <p:sp>
+        <p:nvSpPr>
+          <p:cNvPr id="1975387292" name=""/>
+          <p:cNvSpPr/>
+          <p:nvPr/>
+        </p:nvSpPr>
+        <p:spPr bwMode="auto">
+          <a:xfrm rot="0" flipH="0" flipV="0">
+            <a:off x="2551452" y="3219448"/>
+            <a:ext cx="412749" cy="419098"/>
+          </a:xfrm>
+          <a:prstGeom prst="flowChartAlternateProcess">
+            <a:avLst/>
+          </a:prstGeom>
+          <a:noFill/>
+          <a:ln w="38099" cap="flat" cmpd="sng" algn="ctr">
+            <a:solidFill>
+              <a:srgbClr val="FF0000"/>
+            </a:solidFill>
+            <a:prstDash val="solid"/>
+            <a:miter lim="800000"/>
+          </a:ln>
+        </p:spPr>
+        <p:style>
+          <a:lnRef idx="2">
+            <a:schemeClr val="accent1">
+              <a:shade val="50000"/>
+            </a:schemeClr>
+          </a:lnRef>
+          <a:fillRef idx="1">
+            <a:schemeClr val="accent1"/>
+          </a:fillRef>
+          <a:effectRef idx="0">
+            <a:schemeClr val="accent1"/>
+          </a:effectRef>
+          <a:fontRef idx="minor">
+            <a:schemeClr val="lt1"/>
+          </a:fontRef>
+        </p:style>
+      </p:sp>
+      <p:sp>
+        <p:nvSpPr>
+          <p:cNvPr id="1042432353" name=""/>
+          <p:cNvSpPr txBox="1"/>
+          <p:nvPr/>
+        </p:nvSpPr>
+        <p:spPr bwMode="auto">
+          <a:xfrm rot="0" flipH="0" flipV="0">
+            <a:off x="2735481" y="4982755"/>
+            <a:ext cx="539195" cy="305158"/>
+          </a:xfrm>
+          <a:prstGeom prst="rect">
+            <a:avLst/>
+          </a:prstGeom>
+          <a:noFill/>
+        </p:spPr>
+        <p:txBody>
+          <a:bodyPr vertOverflow="overflow" horzOverflow="overflow" vert="horz" wrap="none" lIns="91440" tIns="45720" rIns="91440" bIns="45720" numCol="1" spcCol="0" rtlCol="0" fromWordArt="0" anchor="t" anchorCtr="0" forceAA="0" upright="0" compatLnSpc="0">
+            <a:spAutoFit/>
+          </a:bodyPr>
+          <a:p>
+            <a:pPr>
+              <a:defRPr/>
+            </a:pPr>
+            <a:r>
+              <a:rPr sz="1400">
+                <a:latin typeface="GenKiGothic2 TC M"/>
+                <a:ea typeface="GenKiGothic2 TC M"/>
+                <a:cs typeface="GenKiGothic2 TC M"/>
+              </a:rPr>
+              <a:t>上升</a:t>
+            </a:r>
+            <a:endParaRPr sz="1400">
+              <a:latin typeface="GenKiGothic2 TC M"/>
+              <a:cs typeface="GenKiGothic2 TC M"/>
+            </a:endParaRPr>
+          </a:p>
+        </p:txBody>
+      </p:sp>
+      <p:sp>
+        <p:nvSpPr>
+          <p:cNvPr id="1044397219" name=""/>
+          <p:cNvSpPr/>
+          <p:nvPr/>
+        </p:nvSpPr>
+        <p:spPr bwMode="auto">
+          <a:xfrm rot="0" flipH="0" flipV="0">
+            <a:off x="2797514" y="3687761"/>
+            <a:ext cx="412749" cy="419098"/>
+          </a:xfrm>
+          <a:prstGeom prst="flowChartAlternateProcess">
+            <a:avLst/>
+          </a:prstGeom>
+          <a:noFill/>
+          <a:ln w="38099" cap="flat" cmpd="sng" algn="ctr">
+            <a:solidFill>
+              <a:srgbClr val="FF0000"/>
+            </a:solidFill>
+            <a:prstDash val="solid"/>
+            <a:miter lim="800000"/>
+          </a:ln>
+        </p:spPr>
+        <p:style>
+          <a:lnRef idx="2">
+            <a:schemeClr val="accent1">
+              <a:shade val="50000"/>
+            </a:schemeClr>
+          </a:lnRef>
+          <a:fillRef idx="1">
+            <a:schemeClr val="accent1"/>
+          </a:fillRef>
+          <a:effectRef idx="0">
+            <a:schemeClr val="accent1"/>
+          </a:effectRef>
+          <a:fontRef idx="minor">
+            <a:schemeClr val="lt1"/>
+          </a:fontRef>
+        </p:style>
+      </p:sp>
+      <p:cxnSp>
+        <p:nvCxnSpPr>
+          <p:cNvPr id="693767294" name=""/>
+          <p:cNvCxnSpPr/>
+          <p:nvPr/>
+        </p:nvCxnSpPr>
+        <p:spPr bwMode="auto">
+          <a:xfrm rot="5399942" flipH="0" flipV="0">
+            <a:off x="2612894" y="4497855"/>
+            <a:ext cx="781988" cy="0"/>
+          </a:xfrm>
+          <a:prstGeom prst="line">
+            <a:avLst/>
+          </a:prstGeom>
+          <a:ln w="38099" cap="flat" cmpd="sng" algn="ctr">
+            <a:solidFill>
+              <a:srgbClr val="FF0000"/>
+            </a:solidFill>
+            <a:prstDash val="solid"/>
+            <a:miter lim="800000"/>
+            <a:tailEnd type="triangle" w="med" len="med"/>
+          </a:ln>
+        </p:spPr>
+        <p:style>
+          <a:lnRef idx="1">
+            <a:schemeClr val="accent1">
+              <a:shade val="50000"/>
+            </a:schemeClr>
+          </a:lnRef>
+          <a:fillRef idx="0">
+            <a:schemeClr val="accent1"/>
+          </a:fillRef>
+          <a:effectRef idx="0">
+            <a:schemeClr val="accent1"/>
+          </a:effectRef>
+          <a:fontRef idx="minor">
+            <a:schemeClr val="tx1"/>
+          </a:fontRef>
+        </p:style>
+      </p:cxnSp>
+      <p:sp>
+        <p:nvSpPr>
+          <p:cNvPr id="1187114650" name=""/>
+          <p:cNvSpPr txBox="1"/>
+          <p:nvPr/>
+        </p:nvSpPr>
+        <p:spPr bwMode="auto">
+          <a:xfrm rot="0" flipH="0" flipV="0">
+            <a:off x="2981542" y="5451067"/>
+            <a:ext cx="539195" cy="305158"/>
+          </a:xfrm>
+          <a:prstGeom prst="rect">
+            <a:avLst/>
+          </a:prstGeom>
+          <a:noFill/>
+        </p:spPr>
+        <p:txBody>
+          <a:bodyPr vertOverflow="overflow" horzOverflow="overflow" vert="horz" wrap="none" lIns="91440" tIns="45720" rIns="91440" bIns="45720" numCol="1" spcCol="0" rtlCol="0" fromWordArt="0" anchor="t" anchorCtr="0" forceAA="0" upright="0" compatLnSpc="0">
+            <a:spAutoFit/>
+          </a:bodyPr>
+          <a:p>
+            <a:pPr>
+              <a:defRPr/>
+            </a:pPr>
+            <a:r>
+              <a:rPr sz="1400">
+                <a:latin typeface="GenKiGothic2 TC M"/>
+                <a:ea typeface="GenKiGothic2 TC M"/>
+                <a:cs typeface="GenKiGothic2 TC M"/>
+              </a:rPr>
+              <a:t>下降</a:t>
+            </a:r>
+            <a:endParaRPr sz="1400">
+              <a:latin typeface="GenKiGothic2 TC M"/>
+              <a:cs typeface="GenKiGothic2 TC M"/>
+            </a:endParaRPr>
+          </a:p>
+        </p:txBody>
+      </p:sp>
+      <p:sp>
+        <p:nvSpPr>
+          <p:cNvPr id="476607363" name=""/>
+          <p:cNvSpPr txBox="1"/>
+          <p:nvPr/>
+        </p:nvSpPr>
+        <p:spPr bwMode="auto">
+          <a:xfrm rot="0" flipH="0" flipV="0">
+            <a:off x="2906060" y="1238248"/>
+            <a:ext cx="894793" cy="305159"/>
+          </a:xfrm>
+          <a:prstGeom prst="rect">
+            <a:avLst/>
+          </a:prstGeom>
+          <a:noFill/>
+        </p:spPr>
+        <p:txBody>
+          <a:bodyPr vertOverflow="overflow" horzOverflow="overflow" vert="horz" wrap="none" lIns="91440" tIns="45720" rIns="91440" bIns="45720" numCol="1" spcCol="0" rtlCol="0" fromWordArt="0" anchor="t" anchorCtr="0" forceAA="0" upright="0" compatLnSpc="0">
+            <a:spAutoFit/>
+          </a:bodyPr>
+          <a:p>
+            <a:pPr>
+              <a:defRPr/>
+            </a:pPr>
+            <a:r>
+              <a:rPr sz="1400">
+                <a:latin typeface="GenKiGothic2 TC M"/>
+                <a:ea typeface="GenKiGothic2 TC M"/>
+                <a:cs typeface="GenKiGothic2 TC M"/>
+              </a:rPr>
+              <a:t>變速檔位</a:t>
+            </a:r>
+            <a:endParaRPr sz="1400">
+              <a:latin typeface="GenKiGothic2 TC M"/>
+              <a:cs typeface="GenKiGothic2 TC M"/>
+            </a:endParaRPr>
+          </a:p>
+        </p:txBody>
+      </p:sp>
+      <p:sp>
+        <p:nvSpPr>
+          <p:cNvPr id="2139218906" name=""/>
+          <p:cNvSpPr/>
+          <p:nvPr/>
+        </p:nvSpPr>
+        <p:spPr bwMode="auto">
+          <a:xfrm rot="0" flipH="0" flipV="0">
+            <a:off x="3810994" y="2857500"/>
+            <a:ext cx="4791657" cy="787270"/>
+          </a:xfrm>
+          <a:prstGeom prst="rect">
+            <a:avLst/>
+          </a:prstGeom>
+          <a:solidFill>
+            <a:schemeClr val="tx1">
+              <a:alpha val="40000"/>
+            </a:schemeClr>
+          </a:solidFill>
+          <a:ln w="12700" cap="flat" cmpd="sng" algn="ctr">
+            <a:noFill/>
+            <a:prstDash val="solid"/>
+            <a:miter lim="800000"/>
+          </a:ln>
+        </p:spPr>
+        <p:style>
+          <a:lnRef idx="2">
+            <a:schemeClr val="accent1">
+              <a:shade val="50000"/>
+            </a:schemeClr>
+          </a:lnRef>
+          <a:fillRef idx="1">
+            <a:schemeClr val="accent1"/>
+          </a:fillRef>
+          <a:effectRef idx="0">
+            <a:schemeClr val="accent1"/>
+          </a:effectRef>
+          <a:fontRef idx="minor">
+            <a:schemeClr val="lt1"/>
+          </a:fontRef>
+        </p:style>
+      </p:sp>
+      <p:sp>
+        <p:nvSpPr>
+          <p:cNvPr id="903430774" name=""/>
+          <p:cNvSpPr txBox="1"/>
+          <p:nvPr/>
+        </p:nvSpPr>
+        <p:spPr bwMode="auto">
+          <a:xfrm rot="0" flipH="0" flipV="0">
+            <a:off x="4010400" y="3034800"/>
+            <a:ext cx="4374465" cy="454680"/>
+          </a:xfrm>
+          <a:prstGeom prst="rect">
+            <a:avLst/>
+          </a:prstGeom>
+          <a:solidFill>
+            <a:schemeClr val="bg1"/>
+          </a:solidFill>
+          <a:ln w="12699">
+            <a:solidFill>
+              <a:schemeClr val="accent1">
+                <a:lumMod val="50196"/>
+              </a:schemeClr>
+            </a:solidFill>
+            <a:prstDash val="solid"/>
+          </a:ln>
+          <a:effectLst/>
+        </p:spPr>
+        <p:txBody>
+          <a:bodyPr vertOverflow="overflow" horzOverflow="overflow" vert="horz" wrap="square" lIns="126000" tIns="90000" rIns="126000" bIns="90000" numCol="1" spcCol="0" rtlCol="0" fromWordArt="0" anchor="t" anchorCtr="0" forceAA="0" upright="0" compatLnSpc="0">
+            <a:spAutoFit/>
+          </a:bodyPr>
+          <a:p>
+            <a:pPr algn="ctr">
+              <a:defRPr/>
+            </a:pPr>
+            <a:r>
+              <a:rPr sz="1800">
+                <a:solidFill>
+                  <a:srgbClr val="0000FF"/>
+                </a:solidFill>
+                <a:latin typeface="GenKiGothic2 TC M"/>
+                <a:ea typeface="GenKiGothic2 TC M"/>
+                <a:cs typeface="GenKiGothic2 TC M"/>
+              </a:rPr>
+              <a:t>點擊說明圖片及地圖部分開始飛行</a:t>
+            </a:r>
+            <a:endParaRPr sz="1800">
+              <a:solidFill>
+                <a:srgbClr val="0000FF"/>
+              </a:solidFill>
+              <a:latin typeface="GenKiGothic2 TC M"/>
+              <a:cs typeface="GenKiGothic2 TC M"/>
+            </a:endParaRPr>
+          </a:p>
+        </p:txBody>
+      </p:sp>
+      <p:sp>
+        <p:nvSpPr>
+          <p:cNvPr id="1009553654" name=""/>
+          <p:cNvSpPr/>
+          <p:nvPr/>
+        </p:nvSpPr>
+        <p:spPr bwMode="auto">
+          <a:xfrm rot="0" flipH="0" flipV="0">
+            <a:off x="1591014" y="3219447"/>
+            <a:ext cx="412749" cy="419097"/>
+          </a:xfrm>
+          <a:prstGeom prst="flowChartAlternateProcess">
+            <a:avLst/>
+          </a:prstGeom>
+          <a:noFill/>
+          <a:ln w="38099" cap="flat" cmpd="sng" algn="ctr">
+            <a:solidFill>
+              <a:srgbClr val="FF0000"/>
+            </a:solidFill>
+            <a:prstDash val="solid"/>
+            <a:miter lim="800000"/>
+          </a:ln>
+        </p:spPr>
+        <p:style>
+          <a:lnRef idx="2">
+            <a:schemeClr val="accent1">
+              <a:shade val="50000"/>
+            </a:schemeClr>
+          </a:lnRef>
+          <a:fillRef idx="1">
+            <a:schemeClr val="accent1"/>
+          </a:fillRef>
+          <a:effectRef idx="0">
+            <a:schemeClr val="accent1"/>
+          </a:effectRef>
+          <a:fontRef idx="minor">
+            <a:schemeClr val="lt1"/>
+          </a:fontRef>
+        </p:style>
+      </p:sp>
+      <p:sp>
+        <p:nvSpPr>
+          <p:cNvPr id="137047250" name=""/>
+          <p:cNvSpPr/>
+          <p:nvPr/>
+        </p:nvSpPr>
+        <p:spPr bwMode="auto">
+          <a:xfrm>
+            <a:off x="1853229" y="4888847"/>
+            <a:ext cx="658810" cy="887410"/>
+          </a:xfrm>
+          <a:custGeom>
+            <a:avLst/>
+            <a:gdLst/>
+            <a:ahLst/>
+            <a:cxnLst/>
+            <a:rect l="0" t="0" r="r" b="b"/>
+            <a:pathLst>
+              <a:path w="658811" h="887411" fill="norm" stroke="1" extrusionOk="0">
+                <a:moveTo>
+                  <a:pt x="303833" y="419098"/>
+                </a:moveTo>
+                <a:cubicBezTo>
+                  <a:pt x="303833" y="419098"/>
+                  <a:pt x="68790" y="419098"/>
+                  <a:pt x="68790" y="419098"/>
+                </a:cubicBezTo>
+                <a:cubicBezTo>
+                  <a:pt x="31052" y="419098"/>
+                  <a:pt x="0" y="388045"/>
+                  <a:pt x="0" y="350307"/>
+                </a:cubicBezTo>
+                <a:cubicBezTo>
+                  <a:pt x="0" y="350307"/>
+                  <a:pt x="0" y="68792"/>
+                  <a:pt x="0" y="68792"/>
+                </a:cubicBezTo>
+                <a:cubicBezTo>
+                  <a:pt x="0" y="31053"/>
+                  <a:pt x="31052" y="0"/>
+                  <a:pt x="68790" y="0"/>
+                </a:cubicBezTo>
+                <a:cubicBezTo>
+                  <a:pt x="68790" y="0"/>
+                  <a:pt x="343957" y="0"/>
+                  <a:pt x="343957" y="0"/>
+                </a:cubicBezTo>
+                <a:cubicBezTo>
+                  <a:pt x="381695" y="0"/>
+                  <a:pt x="412748" y="31053"/>
+                  <a:pt x="412748" y="68792"/>
+                </a:cubicBezTo>
+                <a:cubicBezTo>
+                  <a:pt x="412748" y="68792"/>
+                  <a:pt x="412748" y="350307"/>
+                  <a:pt x="412748" y="350307"/>
+                </a:cubicBezTo>
+                <a:cubicBezTo>
+                  <a:pt x="412748" y="381523"/>
+                  <a:pt x="391500" y="408165"/>
+                  <a:pt x="362797" y="416441"/>
+                </a:cubicBezTo>
+                <a:cubicBezTo>
+                  <a:pt x="362797" y="416441"/>
+                  <a:pt x="362797" y="468313"/>
+                  <a:pt x="362797" y="468313"/>
+                </a:cubicBezTo>
+                <a:cubicBezTo>
+                  <a:pt x="362797" y="468313"/>
+                  <a:pt x="590019" y="468313"/>
+                  <a:pt x="590019" y="468313"/>
+                </a:cubicBezTo>
+                <a:cubicBezTo>
+                  <a:pt x="627756" y="468313"/>
+                  <a:pt x="658811" y="499366"/>
+                  <a:pt x="658811" y="537105"/>
+                </a:cubicBezTo>
+                <a:cubicBezTo>
+                  <a:pt x="658811" y="537105"/>
+                  <a:pt x="658811" y="818620"/>
+                  <a:pt x="658811" y="818620"/>
+                </a:cubicBezTo>
+                <a:cubicBezTo>
+                  <a:pt x="658811" y="856358"/>
+                  <a:pt x="627756" y="887411"/>
+                  <a:pt x="590019" y="887411"/>
+                </a:cubicBezTo>
+                <a:cubicBezTo>
+                  <a:pt x="590019" y="887411"/>
+                  <a:pt x="314853" y="887411"/>
+                  <a:pt x="314853" y="887411"/>
+                </a:cubicBezTo>
+                <a:cubicBezTo>
+                  <a:pt x="277115" y="887411"/>
+                  <a:pt x="246062" y="856358"/>
+                  <a:pt x="246062" y="818620"/>
+                </a:cubicBezTo>
+                <a:cubicBezTo>
+                  <a:pt x="246062" y="818620"/>
+                  <a:pt x="246062" y="537105"/>
+                  <a:pt x="246062" y="537105"/>
+                </a:cubicBezTo>
+                <a:cubicBezTo>
+                  <a:pt x="246062" y="503114"/>
+                  <a:pt x="271254" y="474545"/>
+                  <a:pt x="303833" y="469207"/>
+                </a:cubicBezTo>
+                <a:cubicBezTo>
+                  <a:pt x="303833" y="469207"/>
+                  <a:pt x="303833" y="419098"/>
+                  <a:pt x="303833" y="419098"/>
+                </a:cubicBezTo>
+                <a:close/>
+              </a:path>
+            </a:pathLst>
+          </a:custGeom>
+          <a:noFill/>
+          <a:ln w="12699" cap="flat" cmpd="sng" algn="ctr">
+            <a:solidFill>
+              <a:schemeClr val="tx1"/>
+            </a:solidFill>
+            <a:prstDash val="solid"/>
+            <a:miter lim="800000"/>
+          </a:ln>
+        </p:spPr>
+        <p:style>
+          <a:lnRef idx="2">
+            <a:schemeClr val="accent1">
+              <a:shade val="50000"/>
+            </a:schemeClr>
+          </a:lnRef>
+          <a:fillRef idx="1">
+            <a:schemeClr val="accent1"/>
+          </a:fillRef>
+          <a:effectRef idx="0">
+            <a:schemeClr val="accent1"/>
+          </a:effectRef>
+          <a:fontRef idx="minor">
+            <a:schemeClr val="lt1"/>
+          </a:fontRef>
+        </p:style>
+      </p:sp>
+      <p:sp>
+        <p:nvSpPr>
+          <p:cNvPr id="1168985537" name=""/>
+          <p:cNvSpPr/>
+          <p:nvPr/>
+        </p:nvSpPr>
+        <p:spPr bwMode="auto">
+          <a:xfrm>
+            <a:off x="2798703" y="4925784"/>
+            <a:ext cx="658810" cy="887410"/>
+          </a:xfrm>
+          <a:custGeom>
+            <a:avLst/>
+            <a:gdLst/>
+            <a:ahLst/>
+            <a:cxnLst/>
+            <a:rect l="0" t="0" r="r" b="b"/>
+            <a:pathLst>
+              <a:path w="658811" h="887411" fill="norm" stroke="1" extrusionOk="0">
+                <a:moveTo>
+                  <a:pt x="306323" y="419097"/>
+                </a:moveTo>
+                <a:cubicBezTo>
+                  <a:pt x="306323" y="419097"/>
+                  <a:pt x="68790" y="419097"/>
+                  <a:pt x="68790" y="419097"/>
+                </a:cubicBezTo>
+                <a:cubicBezTo>
+                  <a:pt x="31052" y="419097"/>
+                  <a:pt x="0" y="388043"/>
+                  <a:pt x="0" y="350306"/>
+                </a:cubicBezTo>
+                <a:cubicBezTo>
+                  <a:pt x="0" y="350306"/>
+                  <a:pt x="0" y="68790"/>
+                  <a:pt x="0" y="68790"/>
+                </a:cubicBezTo>
+                <a:cubicBezTo>
+                  <a:pt x="0" y="31052"/>
+                  <a:pt x="31052" y="0"/>
+                  <a:pt x="68790" y="0"/>
+                </a:cubicBezTo>
+                <a:cubicBezTo>
+                  <a:pt x="68790" y="0"/>
+                  <a:pt x="343956" y="0"/>
+                  <a:pt x="343956" y="0"/>
+                </a:cubicBezTo>
+                <a:cubicBezTo>
+                  <a:pt x="381695" y="0"/>
+                  <a:pt x="412748" y="31052"/>
+                  <a:pt x="412748" y="68790"/>
+                </a:cubicBezTo>
+                <a:cubicBezTo>
+                  <a:pt x="412748" y="68790"/>
+                  <a:pt x="412748" y="350306"/>
+                  <a:pt x="412748" y="350306"/>
+                </a:cubicBezTo>
+                <a:cubicBezTo>
+                  <a:pt x="412748" y="380612"/>
+                  <a:pt x="392720" y="406608"/>
+                  <a:pt x="365286" y="415671"/>
+                </a:cubicBezTo>
+                <a:cubicBezTo>
+                  <a:pt x="365286" y="415671"/>
+                  <a:pt x="365286" y="468313"/>
+                  <a:pt x="365286" y="468313"/>
+                </a:cubicBezTo>
+                <a:cubicBezTo>
+                  <a:pt x="365286" y="468313"/>
+                  <a:pt x="590018" y="468313"/>
+                  <a:pt x="590018" y="468313"/>
+                </a:cubicBezTo>
+                <a:cubicBezTo>
+                  <a:pt x="627757" y="468313"/>
+                  <a:pt x="658810" y="499366"/>
+                  <a:pt x="658810" y="537103"/>
+                </a:cubicBezTo>
+                <a:cubicBezTo>
+                  <a:pt x="658810" y="537103"/>
+                  <a:pt x="658810" y="818619"/>
+                  <a:pt x="658810" y="818619"/>
+                </a:cubicBezTo>
+                <a:cubicBezTo>
+                  <a:pt x="658810" y="856356"/>
+                  <a:pt x="627757" y="887410"/>
+                  <a:pt x="590018" y="887410"/>
+                </a:cubicBezTo>
+                <a:cubicBezTo>
+                  <a:pt x="590018" y="887410"/>
+                  <a:pt x="314852" y="887410"/>
+                  <a:pt x="314852" y="887410"/>
+                </a:cubicBezTo>
+                <a:cubicBezTo>
+                  <a:pt x="277115" y="887410"/>
+                  <a:pt x="246062" y="856356"/>
+                  <a:pt x="246062" y="818619"/>
+                </a:cubicBezTo>
+                <a:cubicBezTo>
+                  <a:pt x="246062" y="818619"/>
+                  <a:pt x="246062" y="537103"/>
+                  <a:pt x="246062" y="537103"/>
+                </a:cubicBezTo>
+                <a:cubicBezTo>
+                  <a:pt x="246062" y="502252"/>
+                  <a:pt x="272546" y="473101"/>
+                  <a:pt x="306323" y="468846"/>
+                </a:cubicBezTo>
+                <a:cubicBezTo>
+                  <a:pt x="306323" y="468846"/>
+                  <a:pt x="306323" y="419097"/>
+                  <a:pt x="306323" y="419097"/>
+                </a:cubicBezTo>
+                <a:close/>
+              </a:path>
+            </a:pathLst>
+          </a:custGeom>
+          <a:noFill/>
+          <a:ln w="12699" cap="flat" cmpd="sng" algn="ctr">
+            <a:solidFill>
+              <a:schemeClr val="tx1"/>
+            </a:solidFill>
+            <a:prstDash val="solid"/>
+            <a:miter lim="800000"/>
+          </a:ln>
+        </p:spPr>
+        <p:style>
+          <a:lnRef idx="2">
+            <a:schemeClr val="accent1">
+              <a:shade val="50000"/>
+            </a:schemeClr>
+          </a:lnRef>
+          <a:fillRef idx="1">
+            <a:schemeClr val="accent1"/>
+          </a:fillRef>
+          <a:effectRef idx="0">
+            <a:schemeClr val="accent1"/>
+          </a:effectRef>
+          <a:fontRef idx="minor">
+            <a:schemeClr val="lt1"/>
+          </a:fontRef>
+        </p:style>
       </p:sp>
     </p:spTree>
   </p:cSld>

</xml_diff>